<commit_message>
Fill in the real GitHub URL in the slide deck
Title slide still had the placeholder URL; the thank-you slide had
already been hand-edited with the real repo link. Baked the real URL
into build_slides.js so both slides stay consistent on rebuild.
</commit_message>
<xml_diff>
--- a/report/slides.pptx
+++ b/report/slides.pptx
@@ -4263,7 +4263,7 @@
                 <a:ea typeface="Calibri" pitchFamily="34" charset="-122"/>
                 <a:cs typeface="Calibri" pitchFamily="34" charset="-120"/>
               </a:rPr>
-              <a:t>Code: https://github.com/&lt;your-github-username&gt;/Lithography-Hotspot-Detection-G11</a:t>
+              <a:t>Code: https://github.com/Nukebyt/Data-Balancing-For-Hotspot-Detection</a:t>
             </a:r>
             <a:endParaRPr lang="en-US" sz="1100" dirty="0"/>
           </a:p>
@@ -9114,7 +9114,7 @@
                 <a:ea typeface="Calibri" pitchFamily="34" charset="-122"/>
                 <a:cs typeface="Calibri" pitchFamily="34" charset="-120"/>
               </a:rPr>
-              <a:t>https://github.com/&lt;your-github-username&gt;/Lithography-Hotspot-Detection-G11</a:t>
+              <a:t>https://github.com/Nukebyt/Data-Balancing-For-Hotspot-Detection</a:t>
             </a:r>
             <a:endParaRPr lang="en-US" sz="1500" dirty="0"/>
           </a:p>

</xml_diff>